<commit_message>
session21 capture Foot evidence and crop submission screenshots
</commit_message>
<xml_diff>
--- a/session21-python/deliverables/LabBoard-Session21.pptx
+++ b/session21-python/deliverables/LabBoard-Session21.pptx
@@ -265,6 +265,18 @@
           <a:p>
             <a:r>
               <a:rPr lang="en-GB"/>
+              <a:t>Terminal screenshot refreshed in the actual Foot terminal on 16 October 2026.</a:t>
+            </a:r>
+          </a:p>
+          <a:p>
+            <a:r>
+              <a:rPr lang="en-GB"/>
+              <a:t/>
+            </a:r>
+          </a:p>
+          <a:p>
+            <a:r>
+              <a:rPr lang="en-GB"/>
               <a:t>Sources:</a:t>
             </a:r>
           </a:p>
@@ -284,6 +296,18 @@
             <a:r>
               <a:rPr lang="en-GB"/>
               <a:t>session21-python/Outputs/kubernetes.png</a:t>
+            </a:r>
+          </a:p>
+          <a:p>
+            <a:r>
+              <a:rPr lang="en-GB"/>
+              <a:t/>
+            </a:r>
+          </a:p>
+          <a:p>
+            <a:r>
+              <a:rPr lang="en-GB"/>
+              <a:t>Screenshot cropped to relevant information; captured text is unchanged.</a:t>
             </a:r>
           </a:p>
         </p:txBody>
@@ -550,7 +574,7 @@
           <a:p>
             <a:r>
               <a:rPr lang="en-GB"/>
-              <a:t>Terraform describes the cloud setup as repeatable instructions, and AWS provides the resources. I created a temporary practice network, managed Kubernetes infrastructure and image storage. I recorded the provisioning and cleanup results, then removed the main lab resources. The application demonstration runs locally on Minikube, while the cloud exercise verified infrastructure. The encryption key has a scheduled deletion date of 8 November 2026, as shown in the saved output.</a:t>
+              <a:t>Terraform describes the cloud setup as repeatable instructions, and AWS supplies the resources. On 16 October 2026, the actual Foot terminal recorded 56 created resources, an Active EKS cluster, one Ready t3.small worker and two ECR repositories. The application demonstration uses local Minikube. After capturing the checks, I applied the reviewed destroy plan. The disposable worker paused in a termination lifecycle wait; I continued its exact termination hook so Terraform could finish. Terraform reported 56 destroyed resources. Final queries confirmed empty Terraform state, no lab EKS cluster, VPC or ECR repositories and a terminated worker. Two encryption keys remain scheduled for deletion: the earlier key on 8 November 2026 and the new capture key on 15 November 2026. The screenshot is a rectangular crop of the actual Foot capture; no text was changed.</a:t>
             </a:r>
           </a:p>
           <a:p>
@@ -580,7 +604,19 @@
           <a:p>
             <a:r>
               <a:rPr lang="en-GB"/>
+              <a:t>session21-python/Outputs/terraform-destroy.png</a:t>
+            </a:r>
+          </a:p>
+          <a:p>
+            <a:r>
+              <a:rPr lang="en-GB"/>
               <a:t>session21-python/Outputs/aws-cleanup.png</a:t>
+            </a:r>
+          </a:p>
+          <a:p>
+            <a:r>
+              <a:rPr lang="en-GB"/>
+              <a:t>session21-python/Outputs/foot-captures.json</a:t>
             </a:r>
           </a:p>
           <a:p>
@@ -1206,6 +1242,18 @@
               <a:t>session21-python/Outputs/github-repository.png</a:t>
             </a:r>
           </a:p>
+          <a:p>
+            <a:r>
+              <a:rPr lang="en-GB"/>
+              <a:t/>
+            </a:r>
+          </a:p>
+          <a:p>
+            <a:r>
+              <a:rPr lang="en-GB"/>
+              <a:t>Screenshot cropped to relevant information; captured text is unchanged.</a:t>
+            </a:r>
+          </a:p>
         </p:txBody>
       </p:sp>
     </p:spTree>
@@ -1295,6 +1343,18 @@
               <a:t>session21-python/Outputs/github-pipeline.png</a:t>
             </a:r>
           </a:p>
+          <a:p>
+            <a:r>
+              <a:rPr lang="en-GB"/>
+              <a:t/>
+            </a:r>
+          </a:p>
+          <a:p>
+            <a:r>
+              <a:rPr lang="en-GB"/>
+              <a:t>Screenshot cropped to relevant information; captured text is unchanged.</a:t>
+            </a:r>
+          </a:p>
         </p:txBody>
       </p:sp>
     </p:spTree>
@@ -1363,6 +1423,18 @@
           <a:p>
             <a:r>
               <a:rPr lang="en-GB"/>
+              <a:t>Terminal screenshot refreshed in the actual Foot terminal on 16 October 2026.</a:t>
+            </a:r>
+          </a:p>
+          <a:p>
+            <a:r>
+              <a:rPr lang="en-GB"/>
+              <a:t/>
+            </a:r>
+          </a:p>
+          <a:p>
+            <a:r>
+              <a:rPr lang="en-GB"/>
               <a:t>Sources:</a:t>
             </a:r>
           </a:p>
@@ -1376,6 +1448,18 @@
             <a:r>
               <a:rPr lang="en-GB"/>
               <a:t>session21-python/Outputs/docker-verification.png</a:t>
+            </a:r>
+          </a:p>
+          <a:p>
+            <a:r>
+              <a:rPr lang="en-GB"/>
+              <a:t/>
+            </a:r>
+          </a:p>
+          <a:p>
+            <a:r>
+              <a:rPr lang="en-GB"/>
+              <a:t>Screenshot cropped to relevant information; captured text is unchanged.</a:t>
             </a:r>
           </a:p>
         </p:txBody>
@@ -2044,21 +2128,20 @@
       </p:sp>
       <p:pic>
         <p:nvPicPr>
-          <p:cNvPr id="5" name="Picture 5" descr="Recorded Kubernetes output showing frontend, backend and PostgreSQL pods Running, with their services."/>
+          <p:cNvPr id="5" name="Picture 5" descr="Cropped actual Foot terminal screenshot of running Kubernetes pods and Services in Minikube."/>
           <p:cNvPicPr/>
           <p:nvPr/>
         </p:nvPicPr>
         <p:blipFill>
           <a:blip r:embed="rId2"/>
-          <a:srcRect l="0" t="0" r="0" b="32000"/>
           <a:stretch>
             <a:fillRect/>
           </a:stretch>
         </p:blipFill>
         <p:spPr>
           <a:xfrm>
-            <a:off x="971550" y="2190750"/>
-            <a:ext cx="10248900" cy="3810000"/>
+            <a:off x="1240971" y="2190750"/>
+            <a:ext cx="9710057" cy="3810000"/>
           </a:xfrm>
           <a:prstGeom prst="rect">
             <a:avLst/>
@@ -4138,21 +4221,20 @@
       </p:sp>
       <p:pic>
         <p:nvPicPr>
-          <p:cNvPr id="8" name="Picture 8" descr="Recorded AWS cleanup verification for the practice infrastructure."/>
+          <p:cNvPr id="8" name="Picture 8" descr="Cropped actual Foot terminal showing empty Terraform state, no lab EKS/VPC/ECR resources, a terminated worker and two encryption keys scheduled for deletion."/>
           <p:cNvPicPr/>
           <p:nvPr/>
         </p:nvPicPr>
         <p:blipFill>
           <a:blip r:embed="rId2"/>
-          <a:srcRect l="0" t="0" r="0" b="45000"/>
           <a:stretch>
             <a:fillRect/>
           </a:stretch>
         </p:blipFill>
         <p:spPr>
           <a:xfrm>
-            <a:off x="4305300" y="2686050"/>
-            <a:ext cx="7277100" cy="2438400"/>
+            <a:off x="4305300" y="3048000"/>
+            <a:ext cx="7277100" cy="1622283"/>
           </a:xfrm>
           <a:prstGeom prst="rect">
             <a:avLst/>
@@ -4191,7 +4273,7 @@
                 </a:solidFill>
                 <a:latin typeface="Inter"/>
               </a:rPr>
-              <a:t>Main lab resources removed. Encryption-key deletion scheduled for 8 November 2026.</a:t>
+              <a:t>56 resources removed. Encryption keys scheduled for deletion on 8 and 15 November 2026.</a:t>
             </a:r>
             <a:endParaRPr lang="en-GB" sz="1875" b="0" i="0" u="none">
               <a:solidFill>
@@ -10110,7 +10192,7 @@
         </p:nvPicPr>
         <p:blipFill>
           <a:blip r:embed="rId2"/>
-          <a:srcRect l="0" t="17000" r="0" b="30000"/>
+          <a:srcRect l="0" t="0" r="0" b="45000"/>
           <a:stretch>
             <a:fillRect/>
           </a:stretch>
@@ -10118,7 +10200,7 @@
         <p:spPr>
           <a:xfrm>
             <a:off x="609600" y="2076450"/>
-            <a:ext cx="10972800" cy="4038600"/>
+            <a:ext cx="10972800" cy="3621024"/>
           </a:xfrm>
           <a:prstGeom prst="rect">
             <a:avLst/>
@@ -10463,15 +10545,14 @@
         </p:nvPicPr>
         <p:blipFill>
           <a:blip r:embed="rId2"/>
-          <a:srcRect l="0" t="17000" r="0" b="37000"/>
           <a:stretch>
             <a:fillRect/>
           </a:stretch>
         </p:blipFill>
         <p:spPr>
           <a:xfrm>
-            <a:off x="609600" y="2286000"/>
-            <a:ext cx="10972800" cy="3505200"/>
+            <a:off x="1515702" y="2286000"/>
+            <a:ext cx="9160595" cy="3505200"/>
           </a:xfrm>
           <a:prstGeom prst="rect">
             <a:avLst/>
@@ -10810,21 +10891,20 @@
       </p:sp>
       <p:pic>
         <p:nvPicPr>
-          <p:cNvPr id="5" name="Picture 5" descr="Recorded Docker Compose verification showing three running services and a healthy database."/>
+          <p:cNvPr id="5" name="Picture 5" descr="Cropped actual Foot terminal screenshot of Docker Compose services, non-root users and live API responses."/>
           <p:cNvPicPr/>
           <p:nvPr/>
         </p:nvPicPr>
         <p:blipFill>
           <a:blip r:embed="rId2"/>
-          <a:srcRect l="0" t="0" r="0" b="15000"/>
           <a:stretch>
             <a:fillRect/>
           </a:stretch>
         </p:blipFill>
         <p:spPr>
           <a:xfrm>
-            <a:off x="2000250" y="2190750"/>
-            <a:ext cx="8191500" cy="3810000"/>
+            <a:off x="1049582" y="2190750"/>
+            <a:ext cx="10092837" cy="3810000"/>
           </a:xfrm>
           <a:prstGeom prst="rect">
             <a:avLst/>

</xml_diff>